<commit_message>
Publish Level 3 Lessons 2–13 lesson books, audio, and slides.
Copy the draft books into level3/curriculum, attach the recorded listening files, and rebuild the decks so the notes and credits use the real lengths.
</commit_message>
<xml_diff>
--- a/level3/slides/Level3_Lesson10_Slides.pptx
+++ b/level3/slides/Level3_Lesson10_Slides.pptx
@@ -1185,7 +1185,7 @@
           </a:p>
           <a:p>
             <a:r>
-              <a:t>The audio (about 1:15) is coming soon. When it is ready, it plays the conversation once; press play again for play 2. Until then, read the listening script (at the end of these notes) with a volunteer.</a:t>
+              <a:t>The audio (L3_L10_listening.mp3, about 1:11) plays the conversation once. Press play again for play 2. A third play is fine if the class needs it.</a:t>
             </a:r>
           </a:p>
           <a:p>
@@ -1195,7 +1195,7 @@
           </a:p>
           <a:p>
             <a:r>
-              <a:t>Audio: the listening audio for this lesson (about 1:15) is coming soon. It will use computer-generated voices (Chatterbox TTS cloned from synthetic Kokoro-82M reference clips); no recordings of real people. Until it is ready, read the listening script (in the notes of the Before You Listen slide) with a volunteer. The names and the story are invented.</a:t>
+              <a:t>Audio: synthetic voices, computer-generated (Chatterbox TTS cloned from Kokoro-82M reference clips). No recordings of real people. The names and the story are invented.</a:t>
             </a:r>
           </a:p>
           <a:p>
@@ -1206,86 +1206,6 @@
           <a:p>
             <a:r>
               <a:t>Picture: Twemoji graphics by Twitter, Inc. and other contributors (https://github.com/jdecked/twemoji), CC BY 4.0 (https://creativecommons.org/licenses/by/4.0/); resized and combined, with speech bubbles, signs, and labels (images/CREDITS.md).</a:t>
-            </a:r>
-          </a:p>
-          <a:p>
-            <a:r>
-              <a:t>Listening script (the audio is coming soon; until then, read it aloud with a volunteer at a normal, friendly speed):</a:t>
-            </a:r>
-          </a:p>
-          <a:p>
-            <a:r>
-              <a:t>Narrator: Lesson ten. Listening. Maria is a new worker at a supermarket. Her coworker Tom is teaching her to use a machine. Listen.</a:t>
-            </a:r>
-          </a:p>
-          <a:p>
-            <a:r>
-              <a:t>Tom: Hi, Maria. Welcome to the team! Today I'm going to show you the floor cleaning machine. It's easy.</a:t>
-            </a:r>
-          </a:p>
-          <a:p>
-            <a:r>
-              <a:t>Maria: Great. How do I start?</a:t>
-            </a:r>
-          </a:p>
-          <a:p>
-            <a:r>
-              <a:t>Tom: First, put on your safety goggles. Then, fill the tank with water.</a:t>
-            </a:r>
-          </a:p>
-          <a:p>
-            <a:r>
-              <a:t>Maria: Why do I need goggles?</a:t>
-            </a:r>
-          </a:p>
-          <a:p>
-            <a:r>
-              <a:t>Tom: Because the detergent can hurt your eyes. Next, add one cup of detergent. Not more!</a:t>
-            </a:r>
-          </a:p>
-          <a:p>
-            <a:r>
-              <a:t>Maria: One cup. Got it. What do I do after that?</a:t>
-            </a:r>
-          </a:p>
-          <a:p>
-            <a:r>
-              <a:t>Tom: After that, plug it in and turn it on. A green light comes on.</a:t>
-            </a:r>
-          </a:p>
-          <a:p>
-            <a:r>
-              <a:t>Maria: And then I just push it?</a:t>
-            </a:r>
-          </a:p>
-          <a:p>
-            <a:r>
-              <a:t>Tom: Right. Push it slowly. Don't leave it alone when it's on.</a:t>
-            </a:r>
-          </a:p>
-          <a:p>
-            <a:r>
-              <a:t>Maria: What do I do when I finish?</a:t>
-            </a:r>
-          </a:p>
-          <a:p>
-            <a:r>
-              <a:t>Tom: Finally, turn it off, unplug it, and empty the tank.</a:t>
-            </a:r>
-          </a:p>
-          <a:p>
-            <a:r>
-              <a:t>Maria: Thanks, Tom. Can I try it now?</a:t>
-            </a:r>
-          </a:p>
-          <a:p>
-            <a:r>
-              <a:t>Tom: Sure. Press the start button, and let's go. I'll walk with you.</a:t>
-            </a:r>
-          </a:p>
-          <a:p>
-            <a:r>
-              <a:t>Narrator: That's the end of the listening.</a:t>
             </a:r>
           </a:p>
         </p:txBody>
@@ -2785,7 +2705,7 @@
           </a:p>
           <a:p>
             <a:r>
-              <a:t>Audio: the listening audio for this lesson (about 1:15) is coming soon. It will use computer-generated voices (Chatterbox TTS cloned from synthetic Kokoro-82M reference clips); no recordings of real people. Until it is ready, read the listening script (in the notes of the Before You Listen slide) with a volunteer. The names and the story are invented.</a:t>
+              <a:t>Audio: synthetic voices, computer-generated (Chatterbox TTS cloned from Kokoro-82M reference clips). No recordings of real people. The names and the story are invented.</a:t>
             </a:r>
           </a:p>
           <a:p>
@@ -12352,7 +12272,7 @@
                 <a:ea typeface="Lexend Deca" pitchFamily="34" charset="-122"/>
                 <a:cs typeface="Lexend Deca" pitchFamily="34" charset="-120"/>
               </a:rPr>
-              <a:t>Audio: about 1:15. It plays once.</a:t>
+              <a:t>Audio: about 1:11. It plays once.</a:t>
             </a:r>
             <a:endParaRPr lang="en-US" sz="2200" dirty="0"/>
           </a:p>
@@ -28907,7 +28827,7 @@
                 <a:ea typeface="Lexend Deca" pitchFamily="34" charset="-122"/>
                 <a:cs typeface="Lexend Deca" pitchFamily="34" charset="-120"/>
               </a:rPr>
-              <a:t>Audio (coming soon): synthetic voices made with Chatterbox TTS (MIT License), cloned from short synthetic reference clips made with Kokoro-82M (Apache License 2.0). No recordings of real people. Each file will carry an inaudible Perth watermark marking it as AI-generated. Font: Lexend Deca (OFL 1.1).</a:t>
+              <a:t>Audio: synthetic voices made with Chatterbox TTS (MIT License), cloned from short synthetic reference clips made with Kokoro-82M (Apache License 2.0). No recordings of real people were used. Each file carries an inaudible Perth watermark marking it as AI-generated. Font: Lexend Deca (OFL 1.1).</a:t>
             </a:r>
             <a:endParaRPr lang="en-US" sz="1350" dirty="0" b="0"/>
           </a:p>

</xml_diff>